<commit_message>
docs: add SonarCloud CI pipeline to quality section and stack table
</commit_message>
<xml_diff>
--- a/docs/apresentacao.pptx
+++ b/docs/apresentacao.pptx
@@ -3721,7 +3721,7 @@
                   <a:srgbClr val="94A3B8"/>
                 </a:solidFill>
               </a:rPr>
-              <a:t>Pirâmide de testes · JaCoCo enforce 80% · OWASP Dependency Check</a:t>
+              <a:t>Pirâmide de testes · JaCoCo enforce 80% · OWASP Dependency Check · SonarCloud Quality Gate</a:t>
             </a:r>
           </a:p>
         </p:txBody>
@@ -4467,12 +4467,12 @@
           <a:p>
             <a:pPr algn="l"/>
             <a:r>
-              <a:rPr sz="1200" b="0" i="0">
+              <a:rPr sz="1100" b="0" i="0">
                 <a:solidFill>
                   <a:srgbClr val="14B8A6"/>
                 </a:solidFill>
               </a:rPr>
-              <a:t>mvn test   ·   mvn verify -Ddependency-check.skip=true   ·   mvn dependency-check:check</a:t>
+              <a:t>mvn test   ·   mvn verify   ·   mvn dependency-check:check   ·   GitHub Actions: mvn verify sonar:sonar  →  Quality Gate bloqueante</a:t>
             </a:r>
           </a:p>
         </p:txBody>
@@ -6833,7 +6833,109 @@
       </p:sp>
       <p:sp>
         <p:nvSpPr>
-          <p:cNvPr id="30" name="Rectangle 29"/>
+          <p:cNvPr id="30" name="TextBox 29"/>
+          <p:cNvSpPr txBox="1"/>
+          <p:nvPr/>
+        </p:nvSpPr>
+        <p:spPr>
+          <a:xfrm>
+            <a:off x="228600" y="6501384"/>
+            <a:ext cx="457200" cy="530352"/>
+          </a:xfrm>
+          <a:prstGeom prst="rect">
+            <a:avLst/>
+          </a:prstGeom>
+          <a:noFill/>
+        </p:spPr>
+        <p:txBody>
+          <a:bodyPr wrap="square">
+            <a:spAutoFit/>
+          </a:bodyPr>
+          <a:lstStyle/>
+          <a:p>
+            <a:pPr algn="ctr"/>
+            <a:r>
+              <a:rPr sz="1800" b="0" i="0">
+                <a:solidFill>
+                  <a:srgbClr val="FFFFFF"/>
+                </a:solidFill>
+              </a:rPr>
+              <a:t>✅</a:t>
+            </a:r>
+          </a:p>
+        </p:txBody>
+      </p:sp>
+      <p:sp>
+        <p:nvSpPr>
+          <p:cNvPr id="31" name="TextBox 30"/>
+          <p:cNvSpPr txBox="1"/>
+          <p:nvPr/>
+        </p:nvSpPr>
+        <p:spPr>
+          <a:xfrm>
+            <a:off x="731520" y="6519672"/>
+            <a:ext cx="4114800" cy="320040"/>
+          </a:xfrm>
+          <a:prstGeom prst="rect">
+            <a:avLst/>
+          </a:prstGeom>
+          <a:noFill/>
+        </p:spPr>
+        <p:txBody>
+          <a:bodyPr wrap="square">
+            <a:spAutoFit/>
+          </a:bodyPr>
+          <a:lstStyle/>
+          <a:p>
+            <a:pPr algn="l"/>
+            <a:r>
+              <a:rPr sz="1400" b="1" i="0">
+                <a:solidFill>
+                  <a:srgbClr val="14B8A6"/>
+                </a:solidFill>
+              </a:rPr>
+              <a:t>CI com SonarCloud</a:t>
+            </a:r>
+          </a:p>
+        </p:txBody>
+      </p:sp>
+      <p:sp>
+        <p:nvSpPr>
+          <p:cNvPr id="32" name="TextBox 31"/>
+          <p:cNvSpPr txBox="1"/>
+          <p:nvPr/>
+        </p:nvSpPr>
+        <p:spPr>
+          <a:xfrm>
+            <a:off x="4937760" y="6519672"/>
+            <a:ext cx="6995160" cy="320040"/>
+          </a:xfrm>
+          <a:prstGeom prst="rect">
+            <a:avLst/>
+          </a:prstGeom>
+          <a:noFill/>
+        </p:spPr>
+        <p:txBody>
+          <a:bodyPr wrap="square">
+            <a:spAutoFit/>
+          </a:bodyPr>
+          <a:lstStyle/>
+          <a:p>
+            <a:pPr algn="l"/>
+            <a:r>
+              <a:rPr sz="1200" b="0" i="0">
+                <a:solidFill>
+                  <a:srgbClr val="94A3B8"/>
+                </a:solidFill>
+              </a:rPr>
+              <a:t>GitHub Actions: build → testes → JaCoCo → sonar:sonar · Quality Gate bloqueante na branch main</a:t>
+            </a:r>
+          </a:p>
+        </p:txBody>
+      </p:sp>
+      <p:sp>
+        <p:nvSpPr>
+          <p:cNvPr id="33" name="Rectangle 32"/>
           <p:cNvSpPr/>
           <p:nvPr/>
         </p:nvSpPr>
@@ -6876,7 +6978,7 @@
       </p:sp>
       <p:sp>
         <p:nvSpPr>
-          <p:cNvPr id="31" name="TextBox 30"/>
+          <p:cNvPr id="34" name="TextBox 33"/>
           <p:cNvSpPr txBox="1"/>
           <p:nvPr/>
         </p:nvSpPr>

</xml_diff>

<commit_message>
docs: add technical debt section to delivery document and slides
</commit_message>
<xml_diff>
--- a/docs/apresentacao.pptx
+++ b/docs/apresentacao.pptx
@@ -17,6 +17,7 @@
     <p:sldId id="265" r:id="rId16"/>
     <p:sldId id="266" r:id="rId17"/>
     <p:sldId id="267" r:id="rId18"/>
+    <p:sldId id="268" r:id="rId19"/>
   </p:sldIdLst>
   <p:sldSz cx="12188952" cy="6858000" type="screen4x3"/>
   <p:notesSz cx="6858000" cy="9144000"/>
@@ -4553,7 +4554,7 @@
             <a:avLst/>
           </a:prstGeom>
           <a:solidFill>
-            <a:srgbClr val="14B8A6"/>
+            <a:srgbClr val="F59E0B"/>
           </a:solidFill>
           <a:ln>
             <a:noFill/>
@@ -4607,7 +4608,7 @@
             <a:r>
               <a:rPr sz="4400" b="1" i="0">
                 <a:solidFill>
-                  <a:srgbClr val="14B8A6"/>
+                  <a:srgbClr val="F59E0B"/>
                 </a:solidFill>
               </a:rPr>
               <a:t>10</a:t>
@@ -4644,7 +4645,7 @@
                   <a:srgbClr val="FFFFFF"/>
                 </a:solidFill>
               </a:rPr>
-              <a:t>Demonstração</a:t>
+              <a:t>Débitos Técnicos Conhecidos</a:t>
             </a:r>
           </a:p>
         </p:txBody>
@@ -4678,23 +4679,66 @@
                   <a:srgbClr val="94A3B8"/>
                 </a:solidFill>
               </a:rPr>
-              <a:t>docker-compose up --build  →  http://localhost:8080/swagger-ui.html</a:t>
-            </a:r>
-          </a:p>
-        </p:txBody>
-      </p:sp>
-      <p:sp>
-        <p:nvSpPr>
-          <p:cNvPr id="7" name="Rounded Rectangle 6"/>
+              <a:t>Decisões conscientes de MVP — identificadas, documentadas, priorizadas para a próxima fase</a:t>
+            </a:r>
+          </a:p>
+        </p:txBody>
+      </p:sp>
+      <p:sp>
+        <p:nvSpPr>
+          <p:cNvPr id="7" name="Rectangle 6"/>
           <p:cNvSpPr/>
           <p:nvPr/>
         </p:nvSpPr>
         <p:spPr>
           <a:xfrm>
-            <a:off x="228600" y="1874519"/>
-            <a:ext cx="530352" cy="868680"/>
-          </a:xfrm>
-          <a:prstGeom prst="roundRect">
+            <a:off x="228600" y="1828800"/>
+            <a:ext cx="11731752" cy="1371600"/>
+          </a:xfrm>
+          <a:prstGeom prst="rect">
+            <a:avLst/>
+          </a:prstGeom>
+          <a:solidFill>
+            <a:srgbClr val="162944"/>
+          </a:solidFill>
+          <a:ln>
+            <a:noFill/>
+          </a:ln>
+        </p:spPr>
+        <p:style>
+          <a:lnRef idx="1">
+            <a:schemeClr val="accent1"/>
+          </a:lnRef>
+          <a:fillRef idx="3">
+            <a:schemeClr val="accent1"/>
+          </a:fillRef>
+          <a:effectRef idx="2">
+            <a:schemeClr val="accent1"/>
+          </a:effectRef>
+          <a:fontRef idx="minor">
+            <a:schemeClr val="lt1"/>
+          </a:fontRef>
+        </p:style>
+        <p:txBody>
+          <a:bodyPr rtlCol="0" anchor="ctr"/>
+          <a:lstStyle/>
+          <a:p>
+            <a:pPr algn="ctr"/>
+          </a:p>
+        </p:txBody>
+      </p:sp>
+      <p:sp>
+        <p:nvSpPr>
+          <p:cNvPr id="8" name="Rectangle 7"/>
+          <p:cNvSpPr/>
+          <p:nvPr/>
+        </p:nvSpPr>
+        <p:spPr>
+          <a:xfrm>
+            <a:off x="228600" y="1828800"/>
+            <a:ext cx="64008" cy="1371600"/>
+          </a:xfrm>
+          <a:prstGeom prst="rect">
             <a:avLst/>
           </a:prstGeom>
           <a:solidFill>
@@ -4728,48 +4772,14 @@
       </p:sp>
       <p:sp>
         <p:nvSpPr>
-          <p:cNvPr id="8" name="TextBox 7"/>
-          <p:cNvSpPr txBox="1"/>
-          <p:nvPr/>
-        </p:nvSpPr>
-        <p:spPr>
-          <a:xfrm>
-            <a:off x="228600" y="1874519"/>
-            <a:ext cx="530352" cy="868680"/>
-          </a:xfrm>
-          <a:prstGeom prst="rect">
-            <a:avLst/>
-          </a:prstGeom>
-          <a:noFill/>
-        </p:spPr>
-        <p:txBody>
-          <a:bodyPr wrap="square">
-            <a:spAutoFit/>
-          </a:bodyPr>
-          <a:lstStyle/>
-          <a:p>
-            <a:pPr algn="ctr"/>
-            <a:r>
-              <a:rPr sz="2000" b="1" i="0">
-                <a:solidFill>
-                  <a:srgbClr val="0D172A"/>
-                </a:solidFill>
-              </a:rPr>
-              <a:t>1</a:t>
-            </a:r>
-          </a:p>
-        </p:txBody>
-      </p:sp>
-      <p:sp>
-        <p:nvSpPr>
           <p:cNvPr id="9" name="TextBox 8"/>
           <p:cNvSpPr txBox="1"/>
           <p:nvPr/>
         </p:nvSpPr>
         <p:spPr>
           <a:xfrm>
-            <a:off x="850392" y="1920239"/>
-            <a:ext cx="5212080" cy="365760"/>
+            <a:off x="502920" y="1938528"/>
+            <a:ext cx="11247120" cy="320040"/>
           </a:xfrm>
           <a:prstGeom prst="rect">
             <a:avLst/>
@@ -4789,7 +4799,7 @@
                   <a:srgbClr val="FB923C"/>
                 </a:solidFill>
               </a:rPr>
-              <a:t>Login</a:t>
+              <a:t>Mappers manuais</a:t>
             </a:r>
           </a:p>
         </p:txBody>
@@ -4802,8 +4812,8 @@
         </p:nvSpPr>
         <p:spPr>
           <a:xfrm>
-            <a:off x="850392" y="2331719"/>
-            <a:ext cx="5212080" cy="411480"/>
+            <a:off x="502920" y="2304288"/>
+            <a:ext cx="5303520" cy="685800"/>
           </a:xfrm>
           <a:prstGeom prst="rect">
             <a:avLst/>
@@ -4823,23 +4833,100 @@
                   <a:srgbClr val="94A3B8"/>
                 </a:solidFill>
               </a:rPr>
-              <a:t>POST /api/auth/login — obtém access token + refresh token</a:t>
-            </a:r>
-          </a:p>
-        </p:txBody>
-      </p:sp>
-      <p:sp>
-        <p:nvSpPr>
-          <p:cNvPr id="11" name="Rounded Rectangle 10"/>
+              <a:t>⚠ Conversão JPA Entity ↔ Domain Object feita à mão nos adapters de persistência.</a:t>
+            </a:r>
+          </a:p>
+        </p:txBody>
+      </p:sp>
+      <p:sp>
+        <p:nvSpPr>
+          <p:cNvPr id="11" name="TextBox 10"/>
+          <p:cNvSpPr txBox="1"/>
+          <p:nvPr/>
+        </p:nvSpPr>
+        <p:spPr>
+          <a:xfrm>
+            <a:off x="5989320" y="2304288"/>
+            <a:ext cx="5760720" cy="685800"/>
+          </a:xfrm>
+          <a:prstGeom prst="rect">
+            <a:avLst/>
+          </a:prstGeom>
+          <a:noFill/>
+        </p:spPr>
+        <p:txBody>
+          <a:bodyPr wrap="square">
+            <a:spAutoFit/>
+          </a:bodyPr>
+          <a:lstStyle/>
+          <a:p>
+            <a:pPr algn="l"/>
+            <a:r>
+              <a:rPr sz="1100" b="0" i="0">
+                <a:solidFill>
+                  <a:srgbClr val="FFFFFF"/>
+                </a:solidFill>
+              </a:rPr>
+              <a:t>→ MapStruct — geração em compile-time, campo faltante vira erro de compilação, zero overhead em runtime.</a:t>
+            </a:r>
+          </a:p>
+        </p:txBody>
+      </p:sp>
+      <p:sp>
+        <p:nvSpPr>
+          <p:cNvPr id="12" name="Rectangle 11"/>
           <p:cNvSpPr/>
           <p:nvPr/>
         </p:nvSpPr>
         <p:spPr>
           <a:xfrm>
-            <a:off x="228600" y="2971800"/>
-            <a:ext cx="530352" cy="868680"/>
-          </a:xfrm>
-          <a:prstGeom prst="roundRect">
+            <a:off x="228600" y="3337560"/>
+            <a:ext cx="11731752" cy="1371600"/>
+          </a:xfrm>
+          <a:prstGeom prst="rect">
+            <a:avLst/>
+          </a:prstGeom>
+          <a:solidFill>
+            <a:srgbClr val="162944"/>
+          </a:solidFill>
+          <a:ln>
+            <a:noFill/>
+          </a:ln>
+        </p:spPr>
+        <p:style>
+          <a:lnRef idx="1">
+            <a:schemeClr val="accent1"/>
+          </a:lnRef>
+          <a:fillRef idx="3">
+            <a:schemeClr val="accent1"/>
+          </a:fillRef>
+          <a:effectRef idx="2">
+            <a:schemeClr val="accent1"/>
+          </a:effectRef>
+          <a:fontRef idx="minor">
+            <a:schemeClr val="lt1"/>
+          </a:fontRef>
+        </p:style>
+        <p:txBody>
+          <a:bodyPr rtlCol="0" anchor="ctr"/>
+          <a:lstStyle/>
+          <a:p>
+            <a:pPr algn="ctr"/>
+          </a:p>
+        </p:txBody>
+      </p:sp>
+      <p:sp>
+        <p:nvSpPr>
+          <p:cNvPr id="13" name="Rectangle 12"/>
+          <p:cNvSpPr/>
+          <p:nvPr/>
+        </p:nvSpPr>
+        <p:spPr>
+          <a:xfrm>
+            <a:off x="228600" y="3337560"/>
+            <a:ext cx="64008" cy="1371600"/>
+          </a:xfrm>
+          <a:prstGeom prst="rect">
             <a:avLst/>
           </a:prstGeom>
           <a:solidFill>
@@ -4873,48 +4960,14 @@
       </p:sp>
       <p:sp>
         <p:nvSpPr>
-          <p:cNvPr id="12" name="TextBox 11"/>
-          <p:cNvSpPr txBox="1"/>
-          <p:nvPr/>
-        </p:nvSpPr>
-        <p:spPr>
-          <a:xfrm>
-            <a:off x="228600" y="2971800"/>
-            <a:ext cx="530352" cy="868680"/>
-          </a:xfrm>
-          <a:prstGeom prst="rect">
-            <a:avLst/>
-          </a:prstGeom>
-          <a:noFill/>
-        </p:spPr>
-        <p:txBody>
-          <a:bodyPr wrap="square">
-            <a:spAutoFit/>
-          </a:bodyPr>
-          <a:lstStyle/>
-          <a:p>
-            <a:pPr algn="ctr"/>
-            <a:r>
-              <a:rPr sz="2000" b="1" i="0">
-                <a:solidFill>
-                  <a:srgbClr val="0D172A"/>
-                </a:solidFill>
-              </a:rPr>
-              <a:t>2</a:t>
-            </a:r>
-          </a:p>
-        </p:txBody>
-      </p:sp>
-      <p:sp>
-        <p:nvSpPr>
-          <p:cNvPr id="13" name="TextBox 12"/>
-          <p:cNvSpPr txBox="1"/>
-          <p:nvPr/>
-        </p:nvSpPr>
-        <p:spPr>
-          <a:xfrm>
-            <a:off x="850392" y="3017520"/>
-            <a:ext cx="5212080" cy="365760"/>
+          <p:cNvPr id="14" name="TextBox 13"/>
+          <p:cNvSpPr txBox="1"/>
+          <p:nvPr/>
+        </p:nvSpPr>
+        <p:spPr>
+          <a:xfrm>
+            <a:off x="502920" y="3447288"/>
+            <a:ext cx="11247120" cy="320040"/>
           </a:xfrm>
           <a:prstGeom prst="rect">
             <a:avLst/>
@@ -4934,21 +4987,21 @@
                   <a:srgbClr val="3B82F6"/>
                 </a:solidFill>
               </a:rPr>
-              <a:t>Cadastrar Cliente</a:t>
-            </a:r>
-          </a:p>
-        </p:txBody>
-      </p:sp>
-      <p:sp>
-        <p:nvSpPr>
-          <p:cNvPr id="14" name="TextBox 13"/>
-          <p:cNvSpPr txBox="1"/>
-          <p:nvPr/>
-        </p:nvSpPr>
-        <p:spPr>
-          <a:xfrm>
-            <a:off x="850392" y="3429000"/>
-            <a:ext cx="5212080" cy="411480"/>
+              <a:t>Notificação stub</a:t>
+            </a:r>
+          </a:p>
+        </p:txBody>
+      </p:sp>
+      <p:sp>
+        <p:nvSpPr>
+          <p:cNvPr id="15" name="TextBox 14"/>
+          <p:cNvSpPr txBox="1"/>
+          <p:nvPr/>
+        </p:nvSpPr>
+        <p:spPr>
+          <a:xfrm>
+            <a:off x="502920" y="3813048"/>
+            <a:ext cx="5303520" cy="685800"/>
           </a:xfrm>
           <a:prstGeom prst="rect">
             <a:avLst/>
@@ -4968,23 +5021,100 @@
                   <a:srgbClr val="94A3B8"/>
                 </a:solidFill>
               </a:rPr>
-              <a:t>POST /api/clientes — CPF validado por dígito verificador</a:t>
-            </a:r>
-          </a:p>
-        </p:txBody>
-      </p:sp>
-      <p:sp>
-        <p:nvSpPr>
-          <p:cNvPr id="15" name="Rounded Rectangle 14"/>
+              <a:t>⚠ NotificacaoService é um port sem implementação concreta. E-mail e SMS não são enviados.</a:t>
+            </a:r>
+          </a:p>
+        </p:txBody>
+      </p:sp>
+      <p:sp>
+        <p:nvSpPr>
+          <p:cNvPr id="16" name="TextBox 15"/>
+          <p:cNvSpPr txBox="1"/>
+          <p:nvPr/>
+        </p:nvSpPr>
+        <p:spPr>
+          <a:xfrm>
+            <a:off x="5989320" y="3813048"/>
+            <a:ext cx="5760720" cy="685800"/>
+          </a:xfrm>
+          <a:prstGeom prst="rect">
+            <a:avLst/>
+          </a:prstGeom>
+          <a:noFill/>
+        </p:spPr>
+        <p:txBody>
+          <a:bodyPr wrap="square">
+            <a:spAutoFit/>
+          </a:bodyPr>
+          <a:lstStyle/>
+          <a:p>
+            <a:pPr algn="l"/>
+            <a:r>
+              <a:rPr sz="1100" b="0" i="0">
+                <a:solidFill>
+                  <a:srgbClr val="FFFFFF"/>
+                </a:solidFill>
+              </a:rPr>
+              <a:t>→ Adapter com JavaMail / SendGrid / AWS SES. Canal ainda indefinido — Hot Spot PA2 do Event Storming.</a:t>
+            </a:r>
+          </a:p>
+        </p:txBody>
+      </p:sp>
+      <p:sp>
+        <p:nvSpPr>
+          <p:cNvPr id="17" name="Rectangle 16"/>
           <p:cNvSpPr/>
           <p:nvPr/>
         </p:nvSpPr>
         <p:spPr>
           <a:xfrm>
-            <a:off x="228600" y="4069079"/>
-            <a:ext cx="530352" cy="868680"/>
-          </a:xfrm>
-          <a:prstGeom prst="roundRect">
+            <a:off x="228600" y="4846320"/>
+            <a:ext cx="11731752" cy="1371600"/>
+          </a:xfrm>
+          <a:prstGeom prst="rect">
+            <a:avLst/>
+          </a:prstGeom>
+          <a:solidFill>
+            <a:srgbClr val="162944"/>
+          </a:solidFill>
+          <a:ln>
+            <a:noFill/>
+          </a:ln>
+        </p:spPr>
+        <p:style>
+          <a:lnRef idx="1">
+            <a:schemeClr val="accent1"/>
+          </a:lnRef>
+          <a:fillRef idx="3">
+            <a:schemeClr val="accent1"/>
+          </a:fillRef>
+          <a:effectRef idx="2">
+            <a:schemeClr val="accent1"/>
+          </a:effectRef>
+          <a:fontRef idx="minor">
+            <a:schemeClr val="lt1"/>
+          </a:fontRef>
+        </p:style>
+        <p:txBody>
+          <a:bodyPr rtlCol="0" anchor="ctr"/>
+          <a:lstStyle/>
+          <a:p>
+            <a:pPr algn="ctr"/>
+          </a:p>
+        </p:txBody>
+      </p:sp>
+      <p:sp>
+        <p:nvSpPr>
+          <p:cNvPr id="18" name="Rectangle 17"/>
+          <p:cNvSpPr/>
+          <p:nvPr/>
+        </p:nvSpPr>
+        <p:spPr>
+          <a:xfrm>
+            <a:off x="228600" y="4846320"/>
+            <a:ext cx="64008" cy="1371600"/>
+          </a:xfrm>
+          <a:prstGeom prst="rect">
             <a:avLst/>
           </a:prstGeom>
           <a:solidFill>
@@ -5018,48 +5148,14 @@
       </p:sp>
       <p:sp>
         <p:nvSpPr>
-          <p:cNvPr id="16" name="TextBox 15"/>
-          <p:cNvSpPr txBox="1"/>
-          <p:nvPr/>
-        </p:nvSpPr>
-        <p:spPr>
-          <a:xfrm>
-            <a:off x="228600" y="4069079"/>
-            <a:ext cx="530352" cy="868680"/>
-          </a:xfrm>
-          <a:prstGeom prst="rect">
-            <a:avLst/>
-          </a:prstGeom>
-          <a:noFill/>
-        </p:spPr>
-        <p:txBody>
-          <a:bodyPr wrap="square">
-            <a:spAutoFit/>
-          </a:bodyPr>
-          <a:lstStyle/>
-          <a:p>
-            <a:pPr algn="ctr"/>
-            <a:r>
-              <a:rPr sz="2000" b="1" i="0">
-                <a:solidFill>
-                  <a:srgbClr val="0D172A"/>
-                </a:solidFill>
-              </a:rPr>
-              <a:t>3</a:t>
-            </a:r>
-          </a:p>
-        </p:txBody>
-      </p:sp>
-      <p:sp>
-        <p:nvSpPr>
-          <p:cNvPr id="17" name="TextBox 16"/>
-          <p:cNvSpPr txBox="1"/>
-          <p:nvPr/>
-        </p:nvSpPr>
-        <p:spPr>
-          <a:xfrm>
-            <a:off x="850392" y="4114799"/>
-            <a:ext cx="5212080" cy="365760"/>
+          <p:cNvPr id="19" name="TextBox 18"/>
+          <p:cNvSpPr txBox="1"/>
+          <p:nvPr/>
+        </p:nvSpPr>
+        <p:spPr>
+          <a:xfrm>
+            <a:off x="502920" y="4956048"/>
+            <a:ext cx="11247120" cy="320040"/>
           </a:xfrm>
           <a:prstGeom prst="rect">
             <a:avLst/>
@@ -5079,21 +5175,21 @@
                   <a:srgbClr val="14B8A6"/>
                 </a:solidFill>
               </a:rPr>
-              <a:t>Cadastrar Veículo</a:t>
-            </a:r>
-          </a:p>
-        </p:txBody>
-      </p:sp>
-      <p:sp>
-        <p:nvSpPr>
-          <p:cNvPr id="18" name="TextBox 17"/>
-          <p:cNvSpPr txBox="1"/>
-          <p:nvPr/>
-        </p:nvSpPr>
-        <p:spPr>
-          <a:xfrm>
-            <a:off x="850392" y="4526279"/>
-            <a:ext cx="5212080" cy="411480"/>
+              <a:t>Reconstituidor com 9 parâmetros</a:t>
+            </a:r>
+          </a:p>
+        </p:txBody>
+      </p:sp>
+      <p:sp>
+        <p:nvSpPr>
+          <p:cNvPr id="20" name="TextBox 19"/>
+          <p:cNvSpPr txBox="1"/>
+          <p:nvPr/>
+        </p:nvSpPr>
+        <p:spPr>
+          <a:xfrm>
+            <a:off x="502920" y="5321808"/>
+            <a:ext cx="5303520" cy="685800"/>
           </a:xfrm>
           <a:prstGeom prst="rect">
             <a:avLst/>
@@ -5113,27 +5209,61 @@
                   <a:srgbClr val="94A3B8"/>
                 </a:solidFill>
               </a:rPr>
-              <a:t>POST /api/veiculos — placa formato antigo ou Mercosul</a:t>
-            </a:r>
-          </a:p>
-        </p:txBody>
-      </p:sp>
-      <p:sp>
-        <p:nvSpPr>
-          <p:cNvPr id="19" name="Rounded Rectangle 18"/>
+              <a:t>⚠ Método fromPersistencia em OrdemServico tem 9 parâmetros (Sonar S107).</a:t>
+            </a:r>
+          </a:p>
+        </p:txBody>
+      </p:sp>
+      <p:sp>
+        <p:nvSpPr>
+          <p:cNvPr id="21" name="TextBox 20"/>
+          <p:cNvSpPr txBox="1"/>
+          <p:nvPr/>
+        </p:nvSpPr>
+        <p:spPr>
+          <a:xfrm>
+            <a:off x="5989320" y="5321808"/>
+            <a:ext cx="5760720" cy="685800"/>
+          </a:xfrm>
+          <a:prstGeom prst="rect">
+            <a:avLst/>
+          </a:prstGeom>
+          <a:noFill/>
+        </p:spPr>
+        <p:txBody>
+          <a:bodyPr wrap="square">
+            <a:spAutoFit/>
+          </a:bodyPr>
+          <a:lstStyle/>
+          <a:p>
+            <a:pPr algn="l"/>
+            <a:r>
+              <a:rPr sz="1100" b="0" i="0">
+                <a:solidFill>
+                  <a:srgbClr val="FFFFFF"/>
+                </a:solidFill>
+              </a:rPr>
+              <a:t>→ Encapsular em record DadosOrdemServico — 1 parâmetro, invariantes claras, sem Sonar smell.</a:t>
+            </a:r>
+          </a:p>
+        </p:txBody>
+      </p:sp>
+      <p:sp>
+        <p:nvSpPr>
+          <p:cNvPr id="22" name="Rectangle 21"/>
           <p:cNvSpPr/>
           <p:nvPr/>
         </p:nvSpPr>
         <p:spPr>
           <a:xfrm>
-            <a:off x="228600" y="5166359"/>
-            <a:ext cx="530352" cy="868680"/>
-          </a:xfrm>
-          <a:prstGeom prst="roundRect">
+            <a:off x="0" y="6473952"/>
+            <a:ext cx="12188952" cy="384048"/>
+          </a:xfrm>
+          <a:prstGeom prst="rect">
             <a:avLst/>
           </a:prstGeom>
           <a:solidFill>
-            <a:srgbClr val="F59E0B"/>
+            <a:srgbClr val="1E3A5F"/>
           </a:solidFill>
           <a:ln>
             <a:noFill/>
@@ -5163,682 +5293,34 @@
       </p:sp>
       <p:sp>
         <p:nvSpPr>
-          <p:cNvPr id="20" name="TextBox 19"/>
-          <p:cNvSpPr txBox="1"/>
-          <p:nvPr/>
-        </p:nvSpPr>
-        <p:spPr>
-          <a:xfrm>
-            <a:off x="228600" y="5166359"/>
-            <a:ext cx="530352" cy="868680"/>
-          </a:xfrm>
-          <a:prstGeom prst="rect">
-            <a:avLst/>
-          </a:prstGeom>
-          <a:noFill/>
-        </p:spPr>
-        <p:txBody>
-          <a:bodyPr wrap="square">
-            <a:spAutoFit/>
-          </a:bodyPr>
-          <a:lstStyle/>
-          <a:p>
-            <a:pPr algn="ctr"/>
-            <a:r>
-              <a:rPr sz="2000" b="1" i="0">
-                <a:solidFill>
-                  <a:srgbClr val="0D172A"/>
-                </a:solidFill>
-              </a:rPr>
-              <a:t>4</a:t>
-            </a:r>
-          </a:p>
-        </p:txBody>
-      </p:sp>
-      <p:sp>
-        <p:nvSpPr>
-          <p:cNvPr id="21" name="TextBox 20"/>
-          <p:cNvSpPr txBox="1"/>
-          <p:nvPr/>
-        </p:nvSpPr>
-        <p:spPr>
-          <a:xfrm>
-            <a:off x="850392" y="5212079"/>
-            <a:ext cx="5212080" cy="365760"/>
-          </a:xfrm>
-          <a:prstGeom prst="rect">
-            <a:avLst/>
-          </a:prstGeom>
-          <a:noFill/>
-        </p:spPr>
-        <p:txBody>
-          <a:bodyPr wrap="square">
-            <a:spAutoFit/>
-          </a:bodyPr>
-          <a:lstStyle/>
-          <a:p>
-            <a:pPr algn="l"/>
-            <a:r>
-              <a:rPr sz="1500" b="1" i="0">
-                <a:solidFill>
-                  <a:srgbClr val="F59E0B"/>
-                </a:solidFill>
-              </a:rPr>
-              <a:t>Abrir OS</a:t>
-            </a:r>
-          </a:p>
-        </p:txBody>
-      </p:sp>
-      <p:sp>
-        <p:nvSpPr>
-          <p:cNvPr id="22" name="TextBox 21"/>
-          <p:cNvSpPr txBox="1"/>
-          <p:nvPr/>
-        </p:nvSpPr>
-        <p:spPr>
-          <a:xfrm>
-            <a:off x="850392" y="5623559"/>
-            <a:ext cx="5212080" cy="411480"/>
-          </a:xfrm>
-          <a:prstGeom prst="rect">
-            <a:avLst/>
-          </a:prstGeom>
-          <a:noFill/>
-        </p:spPr>
-        <p:txBody>
-          <a:bodyPr wrap="square">
-            <a:spAutoFit/>
-          </a:bodyPr>
-          <a:lstStyle/>
-          <a:p>
-            <a:pPr algn="l"/>
+          <p:cNvPr id="23" name="TextBox 22"/>
+          <p:cNvSpPr txBox="1"/>
+          <p:nvPr/>
+        </p:nvSpPr>
+        <p:spPr>
+          <a:xfrm>
+            <a:off x="365760" y="6492240"/>
+            <a:ext cx="11795760" cy="320040"/>
+          </a:xfrm>
+          <a:prstGeom prst="rect">
+            <a:avLst/>
+          </a:prstGeom>
+          <a:noFill/>
+        </p:spPr>
+        <p:txBody>
+          <a:bodyPr wrap="square">
+            <a:spAutoFit/>
+          </a:bodyPr>
+          <a:lstStyle/>
+          <a:p>
+            <a:pPr algn="ctr"/>
             <a:r>
               <a:rPr sz="1100" b="0" i="0">
                 <a:solidFill>
                   <a:srgbClr val="94A3B8"/>
                 </a:solidFill>
               </a:rPr>
-              <a:t>POST /api/ordens — status: Recebida</a:t>
-            </a:r>
-          </a:p>
-        </p:txBody>
-      </p:sp>
-      <p:sp>
-        <p:nvSpPr>
-          <p:cNvPr id="23" name="Rounded Rectangle 22"/>
-          <p:cNvSpPr/>
-          <p:nvPr/>
-        </p:nvSpPr>
-        <p:spPr>
-          <a:xfrm>
-            <a:off x="6263640" y="1874519"/>
-            <a:ext cx="530352" cy="868680"/>
-          </a:xfrm>
-          <a:prstGeom prst="roundRect">
-            <a:avLst/>
-          </a:prstGeom>
-          <a:solidFill>
-            <a:srgbClr val="22C55E"/>
-          </a:solidFill>
-          <a:ln>
-            <a:noFill/>
-          </a:ln>
-        </p:spPr>
-        <p:style>
-          <a:lnRef idx="1">
-            <a:schemeClr val="accent1"/>
-          </a:lnRef>
-          <a:fillRef idx="3">
-            <a:schemeClr val="accent1"/>
-          </a:fillRef>
-          <a:effectRef idx="2">
-            <a:schemeClr val="accent1"/>
-          </a:effectRef>
-          <a:fontRef idx="minor">
-            <a:schemeClr val="lt1"/>
-          </a:fontRef>
-        </p:style>
-        <p:txBody>
-          <a:bodyPr rtlCol="0" anchor="ctr"/>
-          <a:lstStyle/>
-          <a:p>
-            <a:pPr algn="ctr"/>
-          </a:p>
-        </p:txBody>
-      </p:sp>
-      <p:sp>
-        <p:nvSpPr>
-          <p:cNvPr id="24" name="TextBox 23"/>
-          <p:cNvSpPr txBox="1"/>
-          <p:nvPr/>
-        </p:nvSpPr>
-        <p:spPr>
-          <a:xfrm>
-            <a:off x="6263640" y="1874519"/>
-            <a:ext cx="530352" cy="868680"/>
-          </a:xfrm>
-          <a:prstGeom prst="rect">
-            <a:avLst/>
-          </a:prstGeom>
-          <a:noFill/>
-        </p:spPr>
-        <p:txBody>
-          <a:bodyPr wrap="square">
-            <a:spAutoFit/>
-          </a:bodyPr>
-          <a:lstStyle/>
-          <a:p>
-            <a:pPr algn="ctr"/>
-            <a:r>
-              <a:rPr sz="2000" b="1" i="0">
-                <a:solidFill>
-                  <a:srgbClr val="0D172A"/>
-                </a:solidFill>
-              </a:rPr>
-              <a:t>5</a:t>
-            </a:r>
-          </a:p>
-        </p:txBody>
-      </p:sp>
-      <p:sp>
-        <p:nvSpPr>
-          <p:cNvPr id="25" name="TextBox 24"/>
-          <p:cNvSpPr txBox="1"/>
-          <p:nvPr/>
-        </p:nvSpPr>
-        <p:spPr>
-          <a:xfrm>
-            <a:off x="6885432" y="1920239"/>
-            <a:ext cx="5212080" cy="365760"/>
-          </a:xfrm>
-          <a:prstGeom prst="rect">
-            <a:avLst/>
-          </a:prstGeom>
-          <a:noFill/>
-        </p:spPr>
-        <p:txBody>
-          <a:bodyPr wrap="square">
-            <a:spAutoFit/>
-          </a:bodyPr>
-          <a:lstStyle/>
-          <a:p>
-            <a:pPr algn="l"/>
-            <a:r>
-              <a:rPr sz="1500" b="1" i="0">
-                <a:solidFill>
-                  <a:srgbClr val="22C55E"/>
-                </a:solidFill>
-              </a:rPr>
-              <a:t>Fluxo completo</a:t>
-            </a:r>
-          </a:p>
-        </p:txBody>
-      </p:sp>
-      <p:sp>
-        <p:nvSpPr>
-          <p:cNvPr id="26" name="TextBox 25"/>
-          <p:cNvSpPr txBox="1"/>
-          <p:nvPr/>
-        </p:nvSpPr>
-        <p:spPr>
-          <a:xfrm>
-            <a:off x="6885432" y="2331719"/>
-            <a:ext cx="5212080" cy="411480"/>
-          </a:xfrm>
-          <a:prstGeom prst="rect">
-            <a:avLst/>
-          </a:prstGeom>
-          <a:noFill/>
-        </p:spPr>
-        <p:txBody>
-          <a:bodyPr wrap="square">
-            <a:spAutoFit/>
-          </a:bodyPr>
-          <a:lstStyle/>
-          <a:p>
-            <a:pPr algn="l"/>
-            <a:r>
-              <a:rPr sz="1100" b="0" i="0">
-                <a:solidFill>
-                  <a:srgbClr val="94A3B8"/>
-                </a:solidFill>
-              </a:rPr>
-              <a:t>iniciar-diagnostico → adicionar itens → gerar-orcamento → aprovar → concluir → entregar</a:t>
-            </a:r>
-          </a:p>
-        </p:txBody>
-      </p:sp>
-      <p:sp>
-        <p:nvSpPr>
-          <p:cNvPr id="27" name="Rounded Rectangle 26"/>
-          <p:cNvSpPr/>
-          <p:nvPr/>
-        </p:nvSpPr>
-        <p:spPr>
-          <a:xfrm>
-            <a:off x="6263640" y="2971800"/>
-            <a:ext cx="530352" cy="868680"/>
-          </a:xfrm>
-          <a:prstGeom prst="roundRect">
-            <a:avLst/>
-          </a:prstGeom>
-          <a:solidFill>
-            <a:srgbClr val="F43F5E"/>
-          </a:solidFill>
-          <a:ln>
-            <a:noFill/>
-          </a:ln>
-        </p:spPr>
-        <p:style>
-          <a:lnRef idx="1">
-            <a:schemeClr val="accent1"/>
-          </a:lnRef>
-          <a:fillRef idx="3">
-            <a:schemeClr val="accent1"/>
-          </a:fillRef>
-          <a:effectRef idx="2">
-            <a:schemeClr val="accent1"/>
-          </a:effectRef>
-          <a:fontRef idx="minor">
-            <a:schemeClr val="lt1"/>
-          </a:fontRef>
-        </p:style>
-        <p:txBody>
-          <a:bodyPr rtlCol="0" anchor="ctr"/>
-          <a:lstStyle/>
-          <a:p>
-            <a:pPr algn="ctr"/>
-          </a:p>
-        </p:txBody>
-      </p:sp>
-      <p:sp>
-        <p:nvSpPr>
-          <p:cNvPr id="28" name="TextBox 27"/>
-          <p:cNvSpPr txBox="1"/>
-          <p:nvPr/>
-        </p:nvSpPr>
-        <p:spPr>
-          <a:xfrm>
-            <a:off x="6263640" y="2971800"/>
-            <a:ext cx="530352" cy="868680"/>
-          </a:xfrm>
-          <a:prstGeom prst="rect">
-            <a:avLst/>
-          </a:prstGeom>
-          <a:noFill/>
-        </p:spPr>
-        <p:txBody>
-          <a:bodyPr wrap="square">
-            <a:spAutoFit/>
-          </a:bodyPr>
-          <a:lstStyle/>
-          <a:p>
-            <a:pPr algn="ctr"/>
-            <a:r>
-              <a:rPr sz="2000" b="1" i="0">
-                <a:solidFill>
-                  <a:srgbClr val="0D172A"/>
-                </a:solidFill>
-              </a:rPr>
-              <a:t>6</a:t>
-            </a:r>
-          </a:p>
-        </p:txBody>
-      </p:sp>
-      <p:sp>
-        <p:nvSpPr>
-          <p:cNvPr id="29" name="TextBox 28"/>
-          <p:cNvSpPr txBox="1"/>
-          <p:nvPr/>
-        </p:nvSpPr>
-        <p:spPr>
-          <a:xfrm>
-            <a:off x="6885432" y="3017520"/>
-            <a:ext cx="5212080" cy="365760"/>
-          </a:xfrm>
-          <a:prstGeom prst="rect">
-            <a:avLst/>
-          </a:prstGeom>
-          <a:noFill/>
-        </p:spPr>
-        <p:txBody>
-          <a:bodyPr wrap="square">
-            <a:spAutoFit/>
-          </a:bodyPr>
-          <a:lstStyle/>
-          <a:p>
-            <a:pPr algn="l"/>
-            <a:r>
-              <a:rPr sz="1500" b="1" i="0">
-                <a:solidFill>
-                  <a:srgbClr val="F43F5E"/>
-                </a:solidFill>
-              </a:rPr>
-              <a:t>Estorno de estoque</a:t>
-            </a:r>
-          </a:p>
-        </p:txBody>
-      </p:sp>
-      <p:sp>
-        <p:nvSpPr>
-          <p:cNvPr id="30" name="TextBox 29"/>
-          <p:cNvSpPr txBox="1"/>
-          <p:nvPr/>
-        </p:nvSpPr>
-        <p:spPr>
-          <a:xfrm>
-            <a:off x="6885432" y="3429000"/>
-            <a:ext cx="5212080" cy="411480"/>
-          </a:xfrm>
-          <a:prstGeom prst="rect">
-            <a:avLst/>
-          </a:prstGeom>
-          <a:noFill/>
-        </p:spPr>
-        <p:txBody>
-          <a:bodyPr wrap="square">
-            <a:spAutoFit/>
-          </a:bodyPr>
-          <a:lstStyle/>
-          <a:p>
-            <a:pPr algn="l"/>
-            <a:r>
-              <a:rPr sz="1100" b="0" i="0">
-                <a:solidFill>
-                  <a:srgbClr val="94A3B8"/>
-                </a:solidFill>
-              </a:rPr>
-              <a:t>POST …/reprovar — itens devolvidos ao estoque atomicamente, status: Cancelada</a:t>
-            </a:r>
-          </a:p>
-        </p:txBody>
-      </p:sp>
-      <p:sp>
-        <p:nvSpPr>
-          <p:cNvPr id="31" name="Rounded Rectangle 30"/>
-          <p:cNvSpPr/>
-          <p:nvPr/>
-        </p:nvSpPr>
-        <p:spPr>
-          <a:xfrm>
-            <a:off x="6263640" y="4069079"/>
-            <a:ext cx="530352" cy="868680"/>
-          </a:xfrm>
-          <a:prstGeom prst="roundRect">
-            <a:avLst/>
-          </a:prstGeom>
-          <a:solidFill>
-            <a:srgbClr val="94A3B8"/>
-          </a:solidFill>
-          <a:ln>
-            <a:noFill/>
-          </a:ln>
-        </p:spPr>
-        <p:style>
-          <a:lnRef idx="1">
-            <a:schemeClr val="accent1"/>
-          </a:lnRef>
-          <a:fillRef idx="3">
-            <a:schemeClr val="accent1"/>
-          </a:fillRef>
-          <a:effectRef idx="2">
-            <a:schemeClr val="accent1"/>
-          </a:effectRef>
-          <a:fontRef idx="minor">
-            <a:schemeClr val="lt1"/>
-          </a:fontRef>
-        </p:style>
-        <p:txBody>
-          <a:bodyPr rtlCol="0" anchor="ctr"/>
-          <a:lstStyle/>
-          <a:p>
-            <a:pPr algn="ctr"/>
-          </a:p>
-        </p:txBody>
-      </p:sp>
-      <p:sp>
-        <p:nvSpPr>
-          <p:cNvPr id="32" name="TextBox 31"/>
-          <p:cNvSpPr txBox="1"/>
-          <p:nvPr/>
-        </p:nvSpPr>
-        <p:spPr>
-          <a:xfrm>
-            <a:off x="6263640" y="4069079"/>
-            <a:ext cx="530352" cy="868680"/>
-          </a:xfrm>
-          <a:prstGeom prst="rect">
-            <a:avLst/>
-          </a:prstGeom>
-          <a:noFill/>
-        </p:spPr>
-        <p:txBody>
-          <a:bodyPr wrap="square">
-            <a:spAutoFit/>
-          </a:bodyPr>
-          <a:lstStyle/>
-          <a:p>
-            <a:pPr algn="ctr"/>
-            <a:r>
-              <a:rPr sz="2000" b="1" i="0">
-                <a:solidFill>
-                  <a:srgbClr val="0D172A"/>
-                </a:solidFill>
-              </a:rPr>
-              <a:t>7</a:t>
-            </a:r>
-          </a:p>
-        </p:txBody>
-      </p:sp>
-      <p:sp>
-        <p:nvSpPr>
-          <p:cNvPr id="33" name="TextBox 32"/>
-          <p:cNvSpPr txBox="1"/>
-          <p:nvPr/>
-        </p:nvSpPr>
-        <p:spPr>
-          <a:xfrm>
-            <a:off x="6885432" y="4114799"/>
-            <a:ext cx="5212080" cy="365760"/>
-          </a:xfrm>
-          <a:prstGeom prst="rect">
-            <a:avLst/>
-          </a:prstGeom>
-          <a:noFill/>
-        </p:spPr>
-        <p:txBody>
-          <a:bodyPr wrap="square">
-            <a:spAutoFit/>
-          </a:bodyPr>
-          <a:lstStyle/>
-          <a:p>
-            <a:pPr algn="l"/>
-            <a:r>
-              <a:rPr sz="1500" b="1" i="0">
-                <a:solidFill>
-                  <a:srgbClr val="94A3B8"/>
-                </a:solidFill>
-              </a:rPr>
-              <a:t>Consulta pública</a:t>
-            </a:r>
-          </a:p>
-        </p:txBody>
-      </p:sp>
-      <p:sp>
-        <p:nvSpPr>
-          <p:cNvPr id="34" name="TextBox 33"/>
-          <p:cNvSpPr txBox="1"/>
-          <p:nvPr/>
-        </p:nvSpPr>
-        <p:spPr>
-          <a:xfrm>
-            <a:off x="6885432" y="4526279"/>
-            <a:ext cx="5212080" cy="411480"/>
-          </a:xfrm>
-          <a:prstGeom prst="rect">
-            <a:avLst/>
-          </a:prstGeom>
-          <a:noFill/>
-        </p:spPr>
-        <p:txBody>
-          <a:bodyPr wrap="square">
-            <a:spAutoFit/>
-          </a:bodyPr>
-          <a:lstStyle/>
-          <a:p>
-            <a:pPr algn="l"/>
-            <a:r>
-              <a:rPr sz="1100" b="0" i="0">
-                <a:solidFill>
-                  <a:srgbClr val="94A3B8"/>
-                </a:solidFill>
-              </a:rPr>
-              <a:t>GET /api/ordens/{id}/status — sem JWT (endpoint público)</a:t>
-            </a:r>
-          </a:p>
-        </p:txBody>
-      </p:sp>
-      <p:sp>
-        <p:nvSpPr>
-          <p:cNvPr id="35" name="Rounded Rectangle 34"/>
-          <p:cNvSpPr/>
-          <p:nvPr/>
-        </p:nvSpPr>
-        <p:spPr>
-          <a:xfrm>
-            <a:off x="6263640" y="5166359"/>
-            <a:ext cx="530352" cy="868680"/>
-          </a:xfrm>
-          <a:prstGeom prst="roundRect">
-            <a:avLst/>
-          </a:prstGeom>
-          <a:solidFill>
-            <a:srgbClr val="14B8A6"/>
-          </a:solidFill>
-          <a:ln>
-            <a:noFill/>
-          </a:ln>
-        </p:spPr>
-        <p:style>
-          <a:lnRef idx="1">
-            <a:schemeClr val="accent1"/>
-          </a:lnRef>
-          <a:fillRef idx="3">
-            <a:schemeClr val="accent1"/>
-          </a:fillRef>
-          <a:effectRef idx="2">
-            <a:schemeClr val="accent1"/>
-          </a:effectRef>
-          <a:fontRef idx="minor">
-            <a:schemeClr val="lt1"/>
-          </a:fontRef>
-        </p:style>
-        <p:txBody>
-          <a:bodyPr rtlCol="0" anchor="ctr"/>
-          <a:lstStyle/>
-          <a:p>
-            <a:pPr algn="ctr"/>
-          </a:p>
-        </p:txBody>
-      </p:sp>
-      <p:sp>
-        <p:nvSpPr>
-          <p:cNvPr id="36" name="TextBox 35"/>
-          <p:cNvSpPr txBox="1"/>
-          <p:nvPr/>
-        </p:nvSpPr>
-        <p:spPr>
-          <a:xfrm>
-            <a:off x="6263640" y="5166359"/>
-            <a:ext cx="530352" cy="868680"/>
-          </a:xfrm>
-          <a:prstGeom prst="rect">
-            <a:avLst/>
-          </a:prstGeom>
-          <a:noFill/>
-        </p:spPr>
-        <p:txBody>
-          <a:bodyPr wrap="square">
-            <a:spAutoFit/>
-          </a:bodyPr>
-          <a:lstStyle/>
-          <a:p>
-            <a:pPr algn="ctr"/>
-            <a:r>
-              <a:rPr sz="2000" b="1" i="0">
-                <a:solidFill>
-                  <a:srgbClr val="0D172A"/>
-                </a:solidFill>
-              </a:rPr>
-              <a:t>8</a:t>
-            </a:r>
-          </a:p>
-        </p:txBody>
-      </p:sp>
-      <p:sp>
-        <p:nvSpPr>
-          <p:cNvPr id="37" name="TextBox 36"/>
-          <p:cNvSpPr txBox="1"/>
-          <p:nvPr/>
-        </p:nvSpPr>
-        <p:spPr>
-          <a:xfrm>
-            <a:off x="6885432" y="5212079"/>
-            <a:ext cx="5212080" cy="365760"/>
-          </a:xfrm>
-          <a:prstGeom prst="rect">
-            <a:avLst/>
-          </a:prstGeom>
-          <a:noFill/>
-        </p:spPr>
-        <p:txBody>
-          <a:bodyPr wrap="square">
-            <a:spAutoFit/>
-          </a:bodyPr>
-          <a:lstStyle/>
-          <a:p>
-            <a:pPr algn="l"/>
-            <a:r>
-              <a:rPr sz="1500" b="1" i="0">
-                <a:solidFill>
-                  <a:srgbClr val="14B8A6"/>
-                </a:solidFill>
-              </a:rPr>
-              <a:t>Relatório</a:t>
-            </a:r>
-          </a:p>
-        </p:txBody>
-      </p:sp>
-      <p:sp>
-        <p:nvSpPr>
-          <p:cNvPr id="38" name="TextBox 37"/>
-          <p:cNvSpPr txBox="1"/>
-          <p:nvPr/>
-        </p:nvSpPr>
-        <p:spPr>
-          <a:xfrm>
-            <a:off x="6885432" y="5623559"/>
-            <a:ext cx="5212080" cy="411480"/>
-          </a:xfrm>
-          <a:prstGeom prst="rect">
-            <a:avLst/>
-          </a:prstGeom>
-          <a:noFill/>
-        </p:spPr>
-        <p:txBody>
-          <a:bodyPr wrap="square">
-            <a:spAutoFit/>
-          </a:bodyPr>
-          <a:lstStyle/>
-          <a:p>
-            <a:pPr algn="l"/>
-            <a:r>
-              <a:rPr sz="1100" b="0" i="0">
-                <a:solidFill>
-                  <a:srgbClr val="94A3B8"/>
-                </a:solidFill>
-              </a:rPr>
-              <a:t>GET /api/ordens/relatorio/tempo-medio — AVG(DataConclusao - DataInicio) SQL nativo</a:t>
+              <a:t>Documentado em README.md e documento de entrega — seção 8</a:t>
             </a:r>
           </a:p>
         </p:txBody>
@@ -5919,6 +5401,586 @@
             <a:avLst/>
           </a:prstGeom>
           <a:solidFill>
+            <a:srgbClr val="14B8A6"/>
+          </a:solidFill>
+          <a:ln>
+            <a:noFill/>
+          </a:ln>
+        </p:spPr>
+        <p:style>
+          <a:lnRef idx="1">
+            <a:schemeClr val="accent1"/>
+          </a:lnRef>
+          <a:fillRef idx="3">
+            <a:schemeClr val="accent1"/>
+          </a:fillRef>
+          <a:effectRef idx="2">
+            <a:schemeClr val="accent1"/>
+          </a:effectRef>
+          <a:fontRef idx="minor">
+            <a:schemeClr val="lt1"/>
+          </a:fontRef>
+        </p:style>
+        <p:txBody>
+          <a:bodyPr rtlCol="0" anchor="ctr"/>
+          <a:lstStyle/>
+          <a:p>
+            <a:pPr algn="ctr"/>
+          </a:p>
+        </p:txBody>
+      </p:sp>
+      <p:sp>
+        <p:nvSpPr>
+          <p:cNvPr id="4" name="TextBox 3"/>
+          <p:cNvSpPr txBox="1"/>
+          <p:nvPr/>
+        </p:nvSpPr>
+        <p:spPr>
+          <a:xfrm>
+            <a:off x="228600" y="137160"/>
+            <a:ext cx="1280160" cy="731520"/>
+          </a:xfrm>
+          <a:prstGeom prst="rect">
+            <a:avLst/>
+          </a:prstGeom>
+          <a:noFill/>
+        </p:spPr>
+        <p:txBody>
+          <a:bodyPr wrap="square">
+            <a:spAutoFit/>
+          </a:bodyPr>
+          <a:lstStyle/>
+          <a:p>
+            <a:pPr algn="l"/>
+            <a:r>
+              <a:rPr sz="4400" b="1" i="0">
+                <a:solidFill>
+                  <a:srgbClr val="14B8A6"/>
+                </a:solidFill>
+              </a:rPr>
+              <a:t>11</a:t>
+            </a:r>
+          </a:p>
+        </p:txBody>
+      </p:sp>
+      <p:sp>
+        <p:nvSpPr>
+          <p:cNvPr id="5" name="TextBox 4"/>
+          <p:cNvSpPr txBox="1"/>
+          <p:nvPr/>
+        </p:nvSpPr>
+        <p:spPr>
+          <a:xfrm>
+            <a:off x="228600" y="868680"/>
+            <a:ext cx="9144000" cy="594360"/>
+          </a:xfrm>
+          <a:prstGeom prst="rect">
+            <a:avLst/>
+          </a:prstGeom>
+          <a:noFill/>
+        </p:spPr>
+        <p:txBody>
+          <a:bodyPr wrap="square">
+            <a:spAutoFit/>
+          </a:bodyPr>
+          <a:lstStyle/>
+          <a:p>
+            <a:pPr algn="l"/>
+            <a:r>
+              <a:rPr sz="3000" b="1" i="0">
+                <a:solidFill>
+                  <a:srgbClr val="FFFFFF"/>
+                </a:solidFill>
+              </a:rPr>
+              <a:t>Demonstração</a:t>
+            </a:r>
+          </a:p>
+        </p:txBody>
+      </p:sp>
+      <p:sp>
+        <p:nvSpPr>
+          <p:cNvPr id="6" name="TextBox 5"/>
+          <p:cNvSpPr txBox="1"/>
+          <p:nvPr/>
+        </p:nvSpPr>
+        <p:spPr>
+          <a:xfrm>
+            <a:off x="228600" y="1463040"/>
+            <a:ext cx="11430000" cy="384048"/>
+          </a:xfrm>
+          <a:prstGeom prst="rect">
+            <a:avLst/>
+          </a:prstGeom>
+          <a:noFill/>
+        </p:spPr>
+        <p:txBody>
+          <a:bodyPr wrap="square">
+            <a:spAutoFit/>
+          </a:bodyPr>
+          <a:lstStyle/>
+          <a:p>
+            <a:pPr algn="l"/>
+            <a:r>
+              <a:rPr sz="1200" b="0" i="1">
+                <a:solidFill>
+                  <a:srgbClr val="94A3B8"/>
+                </a:solidFill>
+              </a:rPr>
+              <a:t>docker-compose up --build  →  http://localhost:8080/swagger-ui.html</a:t>
+            </a:r>
+          </a:p>
+        </p:txBody>
+      </p:sp>
+      <p:sp>
+        <p:nvSpPr>
+          <p:cNvPr id="7" name="Rounded Rectangle 6"/>
+          <p:cNvSpPr/>
+          <p:nvPr/>
+        </p:nvSpPr>
+        <p:spPr>
+          <a:xfrm>
+            <a:off x="228600" y="1874519"/>
+            <a:ext cx="530352" cy="868680"/>
+          </a:xfrm>
+          <a:prstGeom prst="roundRect">
+            <a:avLst/>
+          </a:prstGeom>
+          <a:solidFill>
+            <a:srgbClr val="FB923C"/>
+          </a:solidFill>
+          <a:ln>
+            <a:noFill/>
+          </a:ln>
+        </p:spPr>
+        <p:style>
+          <a:lnRef idx="1">
+            <a:schemeClr val="accent1"/>
+          </a:lnRef>
+          <a:fillRef idx="3">
+            <a:schemeClr val="accent1"/>
+          </a:fillRef>
+          <a:effectRef idx="2">
+            <a:schemeClr val="accent1"/>
+          </a:effectRef>
+          <a:fontRef idx="minor">
+            <a:schemeClr val="lt1"/>
+          </a:fontRef>
+        </p:style>
+        <p:txBody>
+          <a:bodyPr rtlCol="0" anchor="ctr"/>
+          <a:lstStyle/>
+          <a:p>
+            <a:pPr algn="ctr"/>
+          </a:p>
+        </p:txBody>
+      </p:sp>
+      <p:sp>
+        <p:nvSpPr>
+          <p:cNvPr id="8" name="TextBox 7"/>
+          <p:cNvSpPr txBox="1"/>
+          <p:nvPr/>
+        </p:nvSpPr>
+        <p:spPr>
+          <a:xfrm>
+            <a:off x="228600" y="1874519"/>
+            <a:ext cx="530352" cy="868680"/>
+          </a:xfrm>
+          <a:prstGeom prst="rect">
+            <a:avLst/>
+          </a:prstGeom>
+          <a:noFill/>
+        </p:spPr>
+        <p:txBody>
+          <a:bodyPr wrap="square">
+            <a:spAutoFit/>
+          </a:bodyPr>
+          <a:lstStyle/>
+          <a:p>
+            <a:pPr algn="ctr"/>
+            <a:r>
+              <a:rPr sz="2000" b="1" i="0">
+                <a:solidFill>
+                  <a:srgbClr val="0D172A"/>
+                </a:solidFill>
+              </a:rPr>
+              <a:t>1</a:t>
+            </a:r>
+          </a:p>
+        </p:txBody>
+      </p:sp>
+      <p:sp>
+        <p:nvSpPr>
+          <p:cNvPr id="9" name="TextBox 8"/>
+          <p:cNvSpPr txBox="1"/>
+          <p:nvPr/>
+        </p:nvSpPr>
+        <p:spPr>
+          <a:xfrm>
+            <a:off x="850392" y="1920239"/>
+            <a:ext cx="5212080" cy="365760"/>
+          </a:xfrm>
+          <a:prstGeom prst="rect">
+            <a:avLst/>
+          </a:prstGeom>
+          <a:noFill/>
+        </p:spPr>
+        <p:txBody>
+          <a:bodyPr wrap="square">
+            <a:spAutoFit/>
+          </a:bodyPr>
+          <a:lstStyle/>
+          <a:p>
+            <a:pPr algn="l"/>
+            <a:r>
+              <a:rPr sz="1500" b="1" i="0">
+                <a:solidFill>
+                  <a:srgbClr val="FB923C"/>
+                </a:solidFill>
+              </a:rPr>
+              <a:t>Login</a:t>
+            </a:r>
+          </a:p>
+        </p:txBody>
+      </p:sp>
+      <p:sp>
+        <p:nvSpPr>
+          <p:cNvPr id="10" name="TextBox 9"/>
+          <p:cNvSpPr txBox="1"/>
+          <p:nvPr/>
+        </p:nvSpPr>
+        <p:spPr>
+          <a:xfrm>
+            <a:off x="850392" y="2331719"/>
+            <a:ext cx="5212080" cy="411480"/>
+          </a:xfrm>
+          <a:prstGeom prst="rect">
+            <a:avLst/>
+          </a:prstGeom>
+          <a:noFill/>
+        </p:spPr>
+        <p:txBody>
+          <a:bodyPr wrap="square">
+            <a:spAutoFit/>
+          </a:bodyPr>
+          <a:lstStyle/>
+          <a:p>
+            <a:pPr algn="l"/>
+            <a:r>
+              <a:rPr sz="1100" b="0" i="0">
+                <a:solidFill>
+                  <a:srgbClr val="94A3B8"/>
+                </a:solidFill>
+              </a:rPr>
+              <a:t>POST /api/auth/login — obtém access token + refresh token</a:t>
+            </a:r>
+          </a:p>
+        </p:txBody>
+      </p:sp>
+      <p:sp>
+        <p:nvSpPr>
+          <p:cNvPr id="11" name="Rounded Rectangle 10"/>
+          <p:cNvSpPr/>
+          <p:nvPr/>
+        </p:nvSpPr>
+        <p:spPr>
+          <a:xfrm>
+            <a:off x="228600" y="2971800"/>
+            <a:ext cx="530352" cy="868680"/>
+          </a:xfrm>
+          <a:prstGeom prst="roundRect">
+            <a:avLst/>
+          </a:prstGeom>
+          <a:solidFill>
+            <a:srgbClr val="3B82F6"/>
+          </a:solidFill>
+          <a:ln>
+            <a:noFill/>
+          </a:ln>
+        </p:spPr>
+        <p:style>
+          <a:lnRef idx="1">
+            <a:schemeClr val="accent1"/>
+          </a:lnRef>
+          <a:fillRef idx="3">
+            <a:schemeClr val="accent1"/>
+          </a:fillRef>
+          <a:effectRef idx="2">
+            <a:schemeClr val="accent1"/>
+          </a:effectRef>
+          <a:fontRef idx="minor">
+            <a:schemeClr val="lt1"/>
+          </a:fontRef>
+        </p:style>
+        <p:txBody>
+          <a:bodyPr rtlCol="0" anchor="ctr"/>
+          <a:lstStyle/>
+          <a:p>
+            <a:pPr algn="ctr"/>
+          </a:p>
+        </p:txBody>
+      </p:sp>
+      <p:sp>
+        <p:nvSpPr>
+          <p:cNvPr id="12" name="TextBox 11"/>
+          <p:cNvSpPr txBox="1"/>
+          <p:nvPr/>
+        </p:nvSpPr>
+        <p:spPr>
+          <a:xfrm>
+            <a:off x="228600" y="2971800"/>
+            <a:ext cx="530352" cy="868680"/>
+          </a:xfrm>
+          <a:prstGeom prst="rect">
+            <a:avLst/>
+          </a:prstGeom>
+          <a:noFill/>
+        </p:spPr>
+        <p:txBody>
+          <a:bodyPr wrap="square">
+            <a:spAutoFit/>
+          </a:bodyPr>
+          <a:lstStyle/>
+          <a:p>
+            <a:pPr algn="ctr"/>
+            <a:r>
+              <a:rPr sz="2000" b="1" i="0">
+                <a:solidFill>
+                  <a:srgbClr val="0D172A"/>
+                </a:solidFill>
+              </a:rPr>
+              <a:t>2</a:t>
+            </a:r>
+          </a:p>
+        </p:txBody>
+      </p:sp>
+      <p:sp>
+        <p:nvSpPr>
+          <p:cNvPr id="13" name="TextBox 12"/>
+          <p:cNvSpPr txBox="1"/>
+          <p:nvPr/>
+        </p:nvSpPr>
+        <p:spPr>
+          <a:xfrm>
+            <a:off x="850392" y="3017520"/>
+            <a:ext cx="5212080" cy="365760"/>
+          </a:xfrm>
+          <a:prstGeom prst="rect">
+            <a:avLst/>
+          </a:prstGeom>
+          <a:noFill/>
+        </p:spPr>
+        <p:txBody>
+          <a:bodyPr wrap="square">
+            <a:spAutoFit/>
+          </a:bodyPr>
+          <a:lstStyle/>
+          <a:p>
+            <a:pPr algn="l"/>
+            <a:r>
+              <a:rPr sz="1500" b="1" i="0">
+                <a:solidFill>
+                  <a:srgbClr val="3B82F6"/>
+                </a:solidFill>
+              </a:rPr>
+              <a:t>Cadastrar Cliente</a:t>
+            </a:r>
+          </a:p>
+        </p:txBody>
+      </p:sp>
+      <p:sp>
+        <p:nvSpPr>
+          <p:cNvPr id="14" name="TextBox 13"/>
+          <p:cNvSpPr txBox="1"/>
+          <p:nvPr/>
+        </p:nvSpPr>
+        <p:spPr>
+          <a:xfrm>
+            <a:off x="850392" y="3429000"/>
+            <a:ext cx="5212080" cy="411480"/>
+          </a:xfrm>
+          <a:prstGeom prst="rect">
+            <a:avLst/>
+          </a:prstGeom>
+          <a:noFill/>
+        </p:spPr>
+        <p:txBody>
+          <a:bodyPr wrap="square">
+            <a:spAutoFit/>
+          </a:bodyPr>
+          <a:lstStyle/>
+          <a:p>
+            <a:pPr algn="l"/>
+            <a:r>
+              <a:rPr sz="1100" b="0" i="0">
+                <a:solidFill>
+                  <a:srgbClr val="94A3B8"/>
+                </a:solidFill>
+              </a:rPr>
+              <a:t>POST /api/clientes — CPF validado por dígito verificador</a:t>
+            </a:r>
+          </a:p>
+        </p:txBody>
+      </p:sp>
+      <p:sp>
+        <p:nvSpPr>
+          <p:cNvPr id="15" name="Rounded Rectangle 14"/>
+          <p:cNvSpPr/>
+          <p:nvPr/>
+        </p:nvSpPr>
+        <p:spPr>
+          <a:xfrm>
+            <a:off x="228600" y="4069079"/>
+            <a:ext cx="530352" cy="868680"/>
+          </a:xfrm>
+          <a:prstGeom prst="roundRect">
+            <a:avLst/>
+          </a:prstGeom>
+          <a:solidFill>
+            <a:srgbClr val="14B8A6"/>
+          </a:solidFill>
+          <a:ln>
+            <a:noFill/>
+          </a:ln>
+        </p:spPr>
+        <p:style>
+          <a:lnRef idx="1">
+            <a:schemeClr val="accent1"/>
+          </a:lnRef>
+          <a:fillRef idx="3">
+            <a:schemeClr val="accent1"/>
+          </a:fillRef>
+          <a:effectRef idx="2">
+            <a:schemeClr val="accent1"/>
+          </a:effectRef>
+          <a:fontRef idx="minor">
+            <a:schemeClr val="lt1"/>
+          </a:fontRef>
+        </p:style>
+        <p:txBody>
+          <a:bodyPr rtlCol="0" anchor="ctr"/>
+          <a:lstStyle/>
+          <a:p>
+            <a:pPr algn="ctr"/>
+          </a:p>
+        </p:txBody>
+      </p:sp>
+      <p:sp>
+        <p:nvSpPr>
+          <p:cNvPr id="16" name="TextBox 15"/>
+          <p:cNvSpPr txBox="1"/>
+          <p:nvPr/>
+        </p:nvSpPr>
+        <p:spPr>
+          <a:xfrm>
+            <a:off x="228600" y="4069079"/>
+            <a:ext cx="530352" cy="868680"/>
+          </a:xfrm>
+          <a:prstGeom prst="rect">
+            <a:avLst/>
+          </a:prstGeom>
+          <a:noFill/>
+        </p:spPr>
+        <p:txBody>
+          <a:bodyPr wrap="square">
+            <a:spAutoFit/>
+          </a:bodyPr>
+          <a:lstStyle/>
+          <a:p>
+            <a:pPr algn="ctr"/>
+            <a:r>
+              <a:rPr sz="2000" b="1" i="0">
+                <a:solidFill>
+                  <a:srgbClr val="0D172A"/>
+                </a:solidFill>
+              </a:rPr>
+              <a:t>3</a:t>
+            </a:r>
+          </a:p>
+        </p:txBody>
+      </p:sp>
+      <p:sp>
+        <p:nvSpPr>
+          <p:cNvPr id="17" name="TextBox 16"/>
+          <p:cNvSpPr txBox="1"/>
+          <p:nvPr/>
+        </p:nvSpPr>
+        <p:spPr>
+          <a:xfrm>
+            <a:off x="850392" y="4114799"/>
+            <a:ext cx="5212080" cy="365760"/>
+          </a:xfrm>
+          <a:prstGeom prst="rect">
+            <a:avLst/>
+          </a:prstGeom>
+          <a:noFill/>
+        </p:spPr>
+        <p:txBody>
+          <a:bodyPr wrap="square">
+            <a:spAutoFit/>
+          </a:bodyPr>
+          <a:lstStyle/>
+          <a:p>
+            <a:pPr algn="l"/>
+            <a:r>
+              <a:rPr sz="1500" b="1" i="0">
+                <a:solidFill>
+                  <a:srgbClr val="14B8A6"/>
+                </a:solidFill>
+              </a:rPr>
+              <a:t>Cadastrar Veículo</a:t>
+            </a:r>
+          </a:p>
+        </p:txBody>
+      </p:sp>
+      <p:sp>
+        <p:nvSpPr>
+          <p:cNvPr id="18" name="TextBox 17"/>
+          <p:cNvSpPr txBox="1"/>
+          <p:nvPr/>
+        </p:nvSpPr>
+        <p:spPr>
+          <a:xfrm>
+            <a:off x="850392" y="4526279"/>
+            <a:ext cx="5212080" cy="411480"/>
+          </a:xfrm>
+          <a:prstGeom prst="rect">
+            <a:avLst/>
+          </a:prstGeom>
+          <a:noFill/>
+        </p:spPr>
+        <p:txBody>
+          <a:bodyPr wrap="square">
+            <a:spAutoFit/>
+          </a:bodyPr>
+          <a:lstStyle/>
+          <a:p>
+            <a:pPr algn="l"/>
+            <a:r>
+              <a:rPr sz="1100" b="0" i="0">
+                <a:solidFill>
+                  <a:srgbClr val="94A3B8"/>
+                </a:solidFill>
+              </a:rPr>
+              <a:t>POST /api/veiculos — placa formato antigo ou Mercosul</a:t>
+            </a:r>
+          </a:p>
+        </p:txBody>
+      </p:sp>
+      <p:sp>
+        <p:nvSpPr>
+          <p:cNvPr id="19" name="Rounded Rectangle 18"/>
+          <p:cNvSpPr/>
+          <p:nvPr/>
+        </p:nvSpPr>
+        <p:spPr>
+          <a:xfrm>
+            <a:off x="228600" y="5166359"/>
+            <a:ext cx="530352" cy="868680"/>
+          </a:xfrm>
+          <a:prstGeom prst="roundRect">
+            <a:avLst/>
+          </a:prstGeom>
+          <a:solidFill>
             <a:srgbClr val="F59E0B"/>
           </a:solidFill>
           <a:ln>
@@ -5949,6 +6011,792 @@
       </p:sp>
       <p:sp>
         <p:nvSpPr>
+          <p:cNvPr id="20" name="TextBox 19"/>
+          <p:cNvSpPr txBox="1"/>
+          <p:nvPr/>
+        </p:nvSpPr>
+        <p:spPr>
+          <a:xfrm>
+            <a:off x="228600" y="5166359"/>
+            <a:ext cx="530352" cy="868680"/>
+          </a:xfrm>
+          <a:prstGeom prst="rect">
+            <a:avLst/>
+          </a:prstGeom>
+          <a:noFill/>
+        </p:spPr>
+        <p:txBody>
+          <a:bodyPr wrap="square">
+            <a:spAutoFit/>
+          </a:bodyPr>
+          <a:lstStyle/>
+          <a:p>
+            <a:pPr algn="ctr"/>
+            <a:r>
+              <a:rPr sz="2000" b="1" i="0">
+                <a:solidFill>
+                  <a:srgbClr val="0D172A"/>
+                </a:solidFill>
+              </a:rPr>
+              <a:t>4</a:t>
+            </a:r>
+          </a:p>
+        </p:txBody>
+      </p:sp>
+      <p:sp>
+        <p:nvSpPr>
+          <p:cNvPr id="21" name="TextBox 20"/>
+          <p:cNvSpPr txBox="1"/>
+          <p:nvPr/>
+        </p:nvSpPr>
+        <p:spPr>
+          <a:xfrm>
+            <a:off x="850392" y="5212079"/>
+            <a:ext cx="5212080" cy="365760"/>
+          </a:xfrm>
+          <a:prstGeom prst="rect">
+            <a:avLst/>
+          </a:prstGeom>
+          <a:noFill/>
+        </p:spPr>
+        <p:txBody>
+          <a:bodyPr wrap="square">
+            <a:spAutoFit/>
+          </a:bodyPr>
+          <a:lstStyle/>
+          <a:p>
+            <a:pPr algn="l"/>
+            <a:r>
+              <a:rPr sz="1500" b="1" i="0">
+                <a:solidFill>
+                  <a:srgbClr val="F59E0B"/>
+                </a:solidFill>
+              </a:rPr>
+              <a:t>Abrir OS</a:t>
+            </a:r>
+          </a:p>
+        </p:txBody>
+      </p:sp>
+      <p:sp>
+        <p:nvSpPr>
+          <p:cNvPr id="22" name="TextBox 21"/>
+          <p:cNvSpPr txBox="1"/>
+          <p:nvPr/>
+        </p:nvSpPr>
+        <p:spPr>
+          <a:xfrm>
+            <a:off x="850392" y="5623559"/>
+            <a:ext cx="5212080" cy="411480"/>
+          </a:xfrm>
+          <a:prstGeom prst="rect">
+            <a:avLst/>
+          </a:prstGeom>
+          <a:noFill/>
+        </p:spPr>
+        <p:txBody>
+          <a:bodyPr wrap="square">
+            <a:spAutoFit/>
+          </a:bodyPr>
+          <a:lstStyle/>
+          <a:p>
+            <a:pPr algn="l"/>
+            <a:r>
+              <a:rPr sz="1100" b="0" i="0">
+                <a:solidFill>
+                  <a:srgbClr val="94A3B8"/>
+                </a:solidFill>
+              </a:rPr>
+              <a:t>POST /api/ordens — status: Recebida</a:t>
+            </a:r>
+          </a:p>
+        </p:txBody>
+      </p:sp>
+      <p:sp>
+        <p:nvSpPr>
+          <p:cNvPr id="23" name="Rounded Rectangle 22"/>
+          <p:cNvSpPr/>
+          <p:nvPr/>
+        </p:nvSpPr>
+        <p:spPr>
+          <a:xfrm>
+            <a:off x="6263640" y="1874519"/>
+            <a:ext cx="530352" cy="868680"/>
+          </a:xfrm>
+          <a:prstGeom prst="roundRect">
+            <a:avLst/>
+          </a:prstGeom>
+          <a:solidFill>
+            <a:srgbClr val="22C55E"/>
+          </a:solidFill>
+          <a:ln>
+            <a:noFill/>
+          </a:ln>
+        </p:spPr>
+        <p:style>
+          <a:lnRef idx="1">
+            <a:schemeClr val="accent1"/>
+          </a:lnRef>
+          <a:fillRef idx="3">
+            <a:schemeClr val="accent1"/>
+          </a:fillRef>
+          <a:effectRef idx="2">
+            <a:schemeClr val="accent1"/>
+          </a:effectRef>
+          <a:fontRef idx="minor">
+            <a:schemeClr val="lt1"/>
+          </a:fontRef>
+        </p:style>
+        <p:txBody>
+          <a:bodyPr rtlCol="0" anchor="ctr"/>
+          <a:lstStyle/>
+          <a:p>
+            <a:pPr algn="ctr"/>
+          </a:p>
+        </p:txBody>
+      </p:sp>
+      <p:sp>
+        <p:nvSpPr>
+          <p:cNvPr id="24" name="TextBox 23"/>
+          <p:cNvSpPr txBox="1"/>
+          <p:nvPr/>
+        </p:nvSpPr>
+        <p:spPr>
+          <a:xfrm>
+            <a:off x="6263640" y="1874519"/>
+            <a:ext cx="530352" cy="868680"/>
+          </a:xfrm>
+          <a:prstGeom prst="rect">
+            <a:avLst/>
+          </a:prstGeom>
+          <a:noFill/>
+        </p:spPr>
+        <p:txBody>
+          <a:bodyPr wrap="square">
+            <a:spAutoFit/>
+          </a:bodyPr>
+          <a:lstStyle/>
+          <a:p>
+            <a:pPr algn="ctr"/>
+            <a:r>
+              <a:rPr sz="2000" b="1" i="0">
+                <a:solidFill>
+                  <a:srgbClr val="0D172A"/>
+                </a:solidFill>
+              </a:rPr>
+              <a:t>5</a:t>
+            </a:r>
+          </a:p>
+        </p:txBody>
+      </p:sp>
+      <p:sp>
+        <p:nvSpPr>
+          <p:cNvPr id="25" name="TextBox 24"/>
+          <p:cNvSpPr txBox="1"/>
+          <p:nvPr/>
+        </p:nvSpPr>
+        <p:spPr>
+          <a:xfrm>
+            <a:off x="6885432" y="1920239"/>
+            <a:ext cx="5212080" cy="365760"/>
+          </a:xfrm>
+          <a:prstGeom prst="rect">
+            <a:avLst/>
+          </a:prstGeom>
+          <a:noFill/>
+        </p:spPr>
+        <p:txBody>
+          <a:bodyPr wrap="square">
+            <a:spAutoFit/>
+          </a:bodyPr>
+          <a:lstStyle/>
+          <a:p>
+            <a:pPr algn="l"/>
+            <a:r>
+              <a:rPr sz="1500" b="1" i="0">
+                <a:solidFill>
+                  <a:srgbClr val="22C55E"/>
+                </a:solidFill>
+              </a:rPr>
+              <a:t>Fluxo completo</a:t>
+            </a:r>
+          </a:p>
+        </p:txBody>
+      </p:sp>
+      <p:sp>
+        <p:nvSpPr>
+          <p:cNvPr id="26" name="TextBox 25"/>
+          <p:cNvSpPr txBox="1"/>
+          <p:nvPr/>
+        </p:nvSpPr>
+        <p:spPr>
+          <a:xfrm>
+            <a:off x="6885432" y="2331719"/>
+            <a:ext cx="5212080" cy="411480"/>
+          </a:xfrm>
+          <a:prstGeom prst="rect">
+            <a:avLst/>
+          </a:prstGeom>
+          <a:noFill/>
+        </p:spPr>
+        <p:txBody>
+          <a:bodyPr wrap="square">
+            <a:spAutoFit/>
+          </a:bodyPr>
+          <a:lstStyle/>
+          <a:p>
+            <a:pPr algn="l"/>
+            <a:r>
+              <a:rPr sz="1100" b="0" i="0">
+                <a:solidFill>
+                  <a:srgbClr val="94A3B8"/>
+                </a:solidFill>
+              </a:rPr>
+              <a:t>iniciar-diagnostico → adicionar itens → gerar-orcamento → aprovar → concluir → entregar</a:t>
+            </a:r>
+          </a:p>
+        </p:txBody>
+      </p:sp>
+      <p:sp>
+        <p:nvSpPr>
+          <p:cNvPr id="27" name="Rounded Rectangle 26"/>
+          <p:cNvSpPr/>
+          <p:nvPr/>
+        </p:nvSpPr>
+        <p:spPr>
+          <a:xfrm>
+            <a:off x="6263640" y="2971800"/>
+            <a:ext cx="530352" cy="868680"/>
+          </a:xfrm>
+          <a:prstGeom prst="roundRect">
+            <a:avLst/>
+          </a:prstGeom>
+          <a:solidFill>
+            <a:srgbClr val="F43F5E"/>
+          </a:solidFill>
+          <a:ln>
+            <a:noFill/>
+          </a:ln>
+        </p:spPr>
+        <p:style>
+          <a:lnRef idx="1">
+            <a:schemeClr val="accent1"/>
+          </a:lnRef>
+          <a:fillRef idx="3">
+            <a:schemeClr val="accent1"/>
+          </a:fillRef>
+          <a:effectRef idx="2">
+            <a:schemeClr val="accent1"/>
+          </a:effectRef>
+          <a:fontRef idx="minor">
+            <a:schemeClr val="lt1"/>
+          </a:fontRef>
+        </p:style>
+        <p:txBody>
+          <a:bodyPr rtlCol="0" anchor="ctr"/>
+          <a:lstStyle/>
+          <a:p>
+            <a:pPr algn="ctr"/>
+          </a:p>
+        </p:txBody>
+      </p:sp>
+      <p:sp>
+        <p:nvSpPr>
+          <p:cNvPr id="28" name="TextBox 27"/>
+          <p:cNvSpPr txBox="1"/>
+          <p:nvPr/>
+        </p:nvSpPr>
+        <p:spPr>
+          <a:xfrm>
+            <a:off x="6263640" y="2971800"/>
+            <a:ext cx="530352" cy="868680"/>
+          </a:xfrm>
+          <a:prstGeom prst="rect">
+            <a:avLst/>
+          </a:prstGeom>
+          <a:noFill/>
+        </p:spPr>
+        <p:txBody>
+          <a:bodyPr wrap="square">
+            <a:spAutoFit/>
+          </a:bodyPr>
+          <a:lstStyle/>
+          <a:p>
+            <a:pPr algn="ctr"/>
+            <a:r>
+              <a:rPr sz="2000" b="1" i="0">
+                <a:solidFill>
+                  <a:srgbClr val="0D172A"/>
+                </a:solidFill>
+              </a:rPr>
+              <a:t>6</a:t>
+            </a:r>
+          </a:p>
+        </p:txBody>
+      </p:sp>
+      <p:sp>
+        <p:nvSpPr>
+          <p:cNvPr id="29" name="TextBox 28"/>
+          <p:cNvSpPr txBox="1"/>
+          <p:nvPr/>
+        </p:nvSpPr>
+        <p:spPr>
+          <a:xfrm>
+            <a:off x="6885432" y="3017520"/>
+            <a:ext cx="5212080" cy="365760"/>
+          </a:xfrm>
+          <a:prstGeom prst="rect">
+            <a:avLst/>
+          </a:prstGeom>
+          <a:noFill/>
+        </p:spPr>
+        <p:txBody>
+          <a:bodyPr wrap="square">
+            <a:spAutoFit/>
+          </a:bodyPr>
+          <a:lstStyle/>
+          <a:p>
+            <a:pPr algn="l"/>
+            <a:r>
+              <a:rPr sz="1500" b="1" i="0">
+                <a:solidFill>
+                  <a:srgbClr val="F43F5E"/>
+                </a:solidFill>
+              </a:rPr>
+              <a:t>Estorno de estoque</a:t>
+            </a:r>
+          </a:p>
+        </p:txBody>
+      </p:sp>
+      <p:sp>
+        <p:nvSpPr>
+          <p:cNvPr id="30" name="TextBox 29"/>
+          <p:cNvSpPr txBox="1"/>
+          <p:nvPr/>
+        </p:nvSpPr>
+        <p:spPr>
+          <a:xfrm>
+            <a:off x="6885432" y="3429000"/>
+            <a:ext cx="5212080" cy="411480"/>
+          </a:xfrm>
+          <a:prstGeom prst="rect">
+            <a:avLst/>
+          </a:prstGeom>
+          <a:noFill/>
+        </p:spPr>
+        <p:txBody>
+          <a:bodyPr wrap="square">
+            <a:spAutoFit/>
+          </a:bodyPr>
+          <a:lstStyle/>
+          <a:p>
+            <a:pPr algn="l"/>
+            <a:r>
+              <a:rPr sz="1100" b="0" i="0">
+                <a:solidFill>
+                  <a:srgbClr val="94A3B8"/>
+                </a:solidFill>
+              </a:rPr>
+              <a:t>POST …/reprovar — itens devolvidos ao estoque atomicamente, status: Cancelada</a:t>
+            </a:r>
+          </a:p>
+        </p:txBody>
+      </p:sp>
+      <p:sp>
+        <p:nvSpPr>
+          <p:cNvPr id="31" name="Rounded Rectangle 30"/>
+          <p:cNvSpPr/>
+          <p:nvPr/>
+        </p:nvSpPr>
+        <p:spPr>
+          <a:xfrm>
+            <a:off x="6263640" y="4069079"/>
+            <a:ext cx="530352" cy="868680"/>
+          </a:xfrm>
+          <a:prstGeom prst="roundRect">
+            <a:avLst/>
+          </a:prstGeom>
+          <a:solidFill>
+            <a:srgbClr val="94A3B8"/>
+          </a:solidFill>
+          <a:ln>
+            <a:noFill/>
+          </a:ln>
+        </p:spPr>
+        <p:style>
+          <a:lnRef idx="1">
+            <a:schemeClr val="accent1"/>
+          </a:lnRef>
+          <a:fillRef idx="3">
+            <a:schemeClr val="accent1"/>
+          </a:fillRef>
+          <a:effectRef idx="2">
+            <a:schemeClr val="accent1"/>
+          </a:effectRef>
+          <a:fontRef idx="minor">
+            <a:schemeClr val="lt1"/>
+          </a:fontRef>
+        </p:style>
+        <p:txBody>
+          <a:bodyPr rtlCol="0" anchor="ctr"/>
+          <a:lstStyle/>
+          <a:p>
+            <a:pPr algn="ctr"/>
+          </a:p>
+        </p:txBody>
+      </p:sp>
+      <p:sp>
+        <p:nvSpPr>
+          <p:cNvPr id="32" name="TextBox 31"/>
+          <p:cNvSpPr txBox="1"/>
+          <p:nvPr/>
+        </p:nvSpPr>
+        <p:spPr>
+          <a:xfrm>
+            <a:off x="6263640" y="4069079"/>
+            <a:ext cx="530352" cy="868680"/>
+          </a:xfrm>
+          <a:prstGeom prst="rect">
+            <a:avLst/>
+          </a:prstGeom>
+          <a:noFill/>
+        </p:spPr>
+        <p:txBody>
+          <a:bodyPr wrap="square">
+            <a:spAutoFit/>
+          </a:bodyPr>
+          <a:lstStyle/>
+          <a:p>
+            <a:pPr algn="ctr"/>
+            <a:r>
+              <a:rPr sz="2000" b="1" i="0">
+                <a:solidFill>
+                  <a:srgbClr val="0D172A"/>
+                </a:solidFill>
+              </a:rPr>
+              <a:t>7</a:t>
+            </a:r>
+          </a:p>
+        </p:txBody>
+      </p:sp>
+      <p:sp>
+        <p:nvSpPr>
+          <p:cNvPr id="33" name="TextBox 32"/>
+          <p:cNvSpPr txBox="1"/>
+          <p:nvPr/>
+        </p:nvSpPr>
+        <p:spPr>
+          <a:xfrm>
+            <a:off x="6885432" y="4114799"/>
+            <a:ext cx="5212080" cy="365760"/>
+          </a:xfrm>
+          <a:prstGeom prst="rect">
+            <a:avLst/>
+          </a:prstGeom>
+          <a:noFill/>
+        </p:spPr>
+        <p:txBody>
+          <a:bodyPr wrap="square">
+            <a:spAutoFit/>
+          </a:bodyPr>
+          <a:lstStyle/>
+          <a:p>
+            <a:pPr algn="l"/>
+            <a:r>
+              <a:rPr sz="1500" b="1" i="0">
+                <a:solidFill>
+                  <a:srgbClr val="94A3B8"/>
+                </a:solidFill>
+              </a:rPr>
+              <a:t>Consulta pública</a:t>
+            </a:r>
+          </a:p>
+        </p:txBody>
+      </p:sp>
+      <p:sp>
+        <p:nvSpPr>
+          <p:cNvPr id="34" name="TextBox 33"/>
+          <p:cNvSpPr txBox="1"/>
+          <p:nvPr/>
+        </p:nvSpPr>
+        <p:spPr>
+          <a:xfrm>
+            <a:off x="6885432" y="4526279"/>
+            <a:ext cx="5212080" cy="411480"/>
+          </a:xfrm>
+          <a:prstGeom prst="rect">
+            <a:avLst/>
+          </a:prstGeom>
+          <a:noFill/>
+        </p:spPr>
+        <p:txBody>
+          <a:bodyPr wrap="square">
+            <a:spAutoFit/>
+          </a:bodyPr>
+          <a:lstStyle/>
+          <a:p>
+            <a:pPr algn="l"/>
+            <a:r>
+              <a:rPr sz="1100" b="0" i="0">
+                <a:solidFill>
+                  <a:srgbClr val="94A3B8"/>
+                </a:solidFill>
+              </a:rPr>
+              <a:t>GET /api/ordens/{id}/status — sem JWT (endpoint público)</a:t>
+            </a:r>
+          </a:p>
+        </p:txBody>
+      </p:sp>
+      <p:sp>
+        <p:nvSpPr>
+          <p:cNvPr id="35" name="Rounded Rectangle 34"/>
+          <p:cNvSpPr/>
+          <p:nvPr/>
+        </p:nvSpPr>
+        <p:spPr>
+          <a:xfrm>
+            <a:off x="6263640" y="5166359"/>
+            <a:ext cx="530352" cy="868680"/>
+          </a:xfrm>
+          <a:prstGeom prst="roundRect">
+            <a:avLst/>
+          </a:prstGeom>
+          <a:solidFill>
+            <a:srgbClr val="14B8A6"/>
+          </a:solidFill>
+          <a:ln>
+            <a:noFill/>
+          </a:ln>
+        </p:spPr>
+        <p:style>
+          <a:lnRef idx="1">
+            <a:schemeClr val="accent1"/>
+          </a:lnRef>
+          <a:fillRef idx="3">
+            <a:schemeClr val="accent1"/>
+          </a:fillRef>
+          <a:effectRef idx="2">
+            <a:schemeClr val="accent1"/>
+          </a:effectRef>
+          <a:fontRef idx="minor">
+            <a:schemeClr val="lt1"/>
+          </a:fontRef>
+        </p:style>
+        <p:txBody>
+          <a:bodyPr rtlCol="0" anchor="ctr"/>
+          <a:lstStyle/>
+          <a:p>
+            <a:pPr algn="ctr"/>
+          </a:p>
+        </p:txBody>
+      </p:sp>
+      <p:sp>
+        <p:nvSpPr>
+          <p:cNvPr id="36" name="TextBox 35"/>
+          <p:cNvSpPr txBox="1"/>
+          <p:nvPr/>
+        </p:nvSpPr>
+        <p:spPr>
+          <a:xfrm>
+            <a:off x="6263640" y="5166359"/>
+            <a:ext cx="530352" cy="868680"/>
+          </a:xfrm>
+          <a:prstGeom prst="rect">
+            <a:avLst/>
+          </a:prstGeom>
+          <a:noFill/>
+        </p:spPr>
+        <p:txBody>
+          <a:bodyPr wrap="square">
+            <a:spAutoFit/>
+          </a:bodyPr>
+          <a:lstStyle/>
+          <a:p>
+            <a:pPr algn="ctr"/>
+            <a:r>
+              <a:rPr sz="2000" b="1" i="0">
+                <a:solidFill>
+                  <a:srgbClr val="0D172A"/>
+                </a:solidFill>
+              </a:rPr>
+              <a:t>8</a:t>
+            </a:r>
+          </a:p>
+        </p:txBody>
+      </p:sp>
+      <p:sp>
+        <p:nvSpPr>
+          <p:cNvPr id="37" name="TextBox 36"/>
+          <p:cNvSpPr txBox="1"/>
+          <p:nvPr/>
+        </p:nvSpPr>
+        <p:spPr>
+          <a:xfrm>
+            <a:off x="6885432" y="5212079"/>
+            <a:ext cx="5212080" cy="365760"/>
+          </a:xfrm>
+          <a:prstGeom prst="rect">
+            <a:avLst/>
+          </a:prstGeom>
+          <a:noFill/>
+        </p:spPr>
+        <p:txBody>
+          <a:bodyPr wrap="square">
+            <a:spAutoFit/>
+          </a:bodyPr>
+          <a:lstStyle/>
+          <a:p>
+            <a:pPr algn="l"/>
+            <a:r>
+              <a:rPr sz="1500" b="1" i="0">
+                <a:solidFill>
+                  <a:srgbClr val="14B8A6"/>
+                </a:solidFill>
+              </a:rPr>
+              <a:t>Relatório</a:t>
+            </a:r>
+          </a:p>
+        </p:txBody>
+      </p:sp>
+      <p:sp>
+        <p:nvSpPr>
+          <p:cNvPr id="38" name="TextBox 37"/>
+          <p:cNvSpPr txBox="1"/>
+          <p:nvPr/>
+        </p:nvSpPr>
+        <p:spPr>
+          <a:xfrm>
+            <a:off x="6885432" y="5623559"/>
+            <a:ext cx="5212080" cy="411480"/>
+          </a:xfrm>
+          <a:prstGeom prst="rect">
+            <a:avLst/>
+          </a:prstGeom>
+          <a:noFill/>
+        </p:spPr>
+        <p:txBody>
+          <a:bodyPr wrap="square">
+            <a:spAutoFit/>
+          </a:bodyPr>
+          <a:lstStyle/>
+          <a:p>
+            <a:pPr algn="l"/>
+            <a:r>
+              <a:rPr sz="1100" b="0" i="0">
+                <a:solidFill>
+                  <a:srgbClr val="94A3B8"/>
+                </a:solidFill>
+              </a:rPr>
+              <a:t>GET /api/ordens/relatorio/tempo-medio — AVG(DataConclusao - DataInicio) SQL nativo</a:t>
+            </a:r>
+          </a:p>
+        </p:txBody>
+      </p:sp>
+    </p:spTree>
+  </p:cSld>
+  <p:clrMapOvr>
+    <a:masterClrMapping/>
+  </p:clrMapOvr>
+</p:sld>
+</file>
+
+<file path=ppt/slides/slide13.xml><?xml version="1.0" encoding="utf-8"?>
+<p:sld xmlns:a="http://schemas.openxmlformats.org/drawingml/2006/main" xmlns:p="http://schemas.openxmlformats.org/presentationml/2006/main" xmlns:r="http://schemas.openxmlformats.org/officeDocument/2006/relationships">
+  <p:cSld>
+    <p:spTree>
+      <p:nvGrpSpPr>
+        <p:cNvPr id="1" name=""/>
+        <p:cNvGrpSpPr/>
+        <p:nvPr/>
+      </p:nvGrpSpPr>
+      <p:grpSpPr/>
+      <p:sp>
+        <p:nvSpPr>
+          <p:cNvPr id="2" name="Rectangle 1"/>
+          <p:cNvSpPr/>
+          <p:nvPr/>
+        </p:nvSpPr>
+        <p:spPr>
+          <a:xfrm>
+            <a:off x="0" y="0"/>
+            <a:ext cx="12188952" cy="6858000"/>
+          </a:xfrm>
+          <a:prstGeom prst="rect">
+            <a:avLst/>
+          </a:prstGeom>
+          <a:solidFill>
+            <a:srgbClr val="0D172A"/>
+          </a:solidFill>
+          <a:ln>
+            <a:noFill/>
+          </a:ln>
+        </p:spPr>
+        <p:style>
+          <a:lnRef idx="1">
+            <a:schemeClr val="accent1"/>
+          </a:lnRef>
+          <a:fillRef idx="3">
+            <a:schemeClr val="accent1"/>
+          </a:fillRef>
+          <a:effectRef idx="2">
+            <a:schemeClr val="accent1"/>
+          </a:effectRef>
+          <a:fontRef idx="minor">
+            <a:schemeClr val="lt1"/>
+          </a:fontRef>
+        </p:style>
+        <p:txBody>
+          <a:bodyPr rtlCol="0" anchor="ctr"/>
+          <a:lstStyle/>
+          <a:p>
+            <a:pPr algn="ctr"/>
+          </a:p>
+        </p:txBody>
+      </p:sp>
+      <p:sp>
+        <p:nvSpPr>
+          <p:cNvPr id="3" name="Rectangle 2"/>
+          <p:cNvSpPr/>
+          <p:nvPr/>
+        </p:nvSpPr>
+        <p:spPr>
+          <a:xfrm>
+            <a:off x="0" y="0"/>
+            <a:ext cx="64008" cy="6858000"/>
+          </a:xfrm>
+          <a:prstGeom prst="rect">
+            <a:avLst/>
+          </a:prstGeom>
+          <a:solidFill>
+            <a:srgbClr val="F59E0B"/>
+          </a:solidFill>
+          <a:ln>
+            <a:noFill/>
+          </a:ln>
+        </p:spPr>
+        <p:style>
+          <a:lnRef idx="1">
+            <a:schemeClr val="accent1"/>
+          </a:lnRef>
+          <a:fillRef idx="3">
+            <a:schemeClr val="accent1"/>
+          </a:fillRef>
+          <a:effectRef idx="2">
+            <a:schemeClr val="accent1"/>
+          </a:effectRef>
+          <a:fontRef idx="minor">
+            <a:schemeClr val="lt1"/>
+          </a:fontRef>
+        </p:style>
+        <p:txBody>
+          <a:bodyPr rtlCol="0" anchor="ctr"/>
+          <a:lstStyle/>
+          <a:p>
+            <a:pPr algn="ctr"/>
+          </a:p>
+        </p:txBody>
+      </p:sp>
+      <p:sp>
+        <p:nvSpPr>
           <p:cNvPr id="4" name="TextBox 3"/>
           <p:cNvSpPr txBox="1"/>
           <p:nvPr/>
@@ -5976,7 +6824,7 @@
                   <a:srgbClr val="F59E0B"/>
                 </a:solidFill>
               </a:rPr>
-              <a:t>11</a:t>
+              <a:t>12</a:t>
             </a:r>
           </a:p>
         </p:txBody>

</xml_diff>